<commit_message>
Apply 15-badge model and six levels across all files; rebuild package
- Badges: C1-C5 core, B1-B5 specialist, A1-A5 advanced; no certification.
- Levels L0-L5: L1/L2 automatic, leveling tests for L3-L5, annual top 10%.
- Removed the Google Workspace HIPAA BAA risk everywhere.
- Re-exported all docs, deck (24 slides), infographic and web app PDFs;
  rebuilt the package folder and zip.

Co-Authored-By: Claude Opus 5.5 <noreply@anthropic.com>
Claude-Session: https://claude.ai/code/session_01Ss3iUTtC1tcixrNE6cvHqv
</commit_message>
<xml_diff>
--- a/oon-operating-model/ER-OON-2027-Package/01-Presentation/ER-OON-Operating-Model-2027-Deck.pptx
+++ b/oon-operating-model/ER-OON-2027-Package/01-Presentation/ER-OON-Operating-Model-2027-Deck.pptx
@@ -28,8 +28,9 @@
     <p:sldId id="276" r:id="rId27"/>
     <p:sldId id="277" r:id="rId28"/>
     <p:sldId id="278" r:id="rId29"/>
+    <p:sldId id="279" r:id="rId30"/>
   </p:sldIdLst>
-  <p:sldSz cx="12191695" cy="6858000" type="screen4x3"/>
+  <p:sldSz cx="12192000" cy="6858000" type="screen4x3"/>
   <p:notesSz cx="6858000" cy="9144000"/>
   <p:defaultTextStyle>
     <a:defPPr>
@@ -3127,7 +3128,7 @@
         <p:spPr>
           <a:xfrm>
             <a:off x="0" y="0"/>
-            <a:ext cx="12191695" cy="6858000"/>
+            <a:ext cx="12192000" cy="6858000"/>
           </a:xfrm>
           <a:prstGeom prst="rect">
             <a:avLst/>
@@ -3169,7 +3170,7 @@
         <p:spPr>
           <a:xfrm>
             <a:off x="0" y="0"/>
-            <a:ext cx="12191695" cy="6858000"/>
+            <a:ext cx="12192000" cy="6858000"/>
           </a:xfrm>
           <a:prstGeom prst="rect">
             <a:avLst/>
@@ -3211,7 +3212,7 @@
         <p:spPr>
           <a:xfrm>
             <a:off x="0" y="0"/>
-            <a:ext cx="12191695" cy="6858000"/>
+            <a:ext cx="12192000" cy="6858000"/>
           </a:xfrm>
           <a:prstGeom prst="rect">
             <a:avLst/>
@@ -3253,7 +3254,7 @@
         <p:spPr>
           <a:xfrm>
             <a:off x="0" y="0"/>
-            <a:ext cx="12191695" cy="6858000"/>
+            <a:ext cx="12192000" cy="6858000"/>
           </a:xfrm>
           <a:prstGeom prst="rect">
             <a:avLst/>
@@ -3280,7 +3281,7 @@
       <p:grpSpPr/>
       <p:pic>
         <p:nvPicPr>
-          <p:cNvPr id="2" name="Picture 1" descr="13-pay.png"/>
+          <p:cNvPr id="2" name="Picture 1" descr="13-badges.png"/>
           <p:cNvPicPr>
             <a:picLocks noChangeAspect="1"/>
           </p:cNvPicPr>
@@ -3295,7 +3296,7 @@
         <p:spPr>
           <a:xfrm>
             <a:off x="0" y="0"/>
-            <a:ext cx="12191695" cy="6858000"/>
+            <a:ext cx="12192000" cy="6858000"/>
           </a:xfrm>
           <a:prstGeom prst="rect">
             <a:avLst/>
@@ -3322,7 +3323,7 @@
       <p:grpSpPr/>
       <p:pic>
         <p:nvPicPr>
-          <p:cNvPr id="2" name="Picture 1" descr="14-testing.png"/>
+          <p:cNvPr id="2" name="Picture 1" descr="14-pay.png"/>
           <p:cNvPicPr>
             <a:picLocks noChangeAspect="1"/>
           </p:cNvPicPr>
@@ -3337,7 +3338,7 @@
         <p:spPr>
           <a:xfrm>
             <a:off x="0" y="0"/>
-            <a:ext cx="12191695" cy="6858000"/>
+            <a:ext cx="12192000" cy="6858000"/>
           </a:xfrm>
           <a:prstGeom prst="rect">
             <a:avLst/>
@@ -3364,7 +3365,7 @@
       <p:grpSpPr/>
       <p:pic>
         <p:nvPicPr>
-          <p:cNvPr id="2" name="Picture 1" descr="15-transition.png"/>
+          <p:cNvPr id="2" name="Picture 1" descr="15-testing.png"/>
           <p:cNvPicPr>
             <a:picLocks noChangeAspect="1"/>
           </p:cNvPicPr>
@@ -3379,7 +3380,7 @@
         <p:spPr>
           <a:xfrm>
             <a:off x="0" y="0"/>
-            <a:ext cx="12191695" cy="6858000"/>
+            <a:ext cx="12192000" cy="6858000"/>
           </a:xfrm>
           <a:prstGeom prst="rect">
             <a:avLst/>
@@ -3406,7 +3407,7 @@
       <p:grpSpPr/>
       <p:pic>
         <p:nvPicPr>
-          <p:cNvPr id="2" name="Picture 1" descr="16-people.png"/>
+          <p:cNvPr id="2" name="Picture 1" descr="16-transition.png"/>
           <p:cNvPicPr>
             <a:picLocks noChangeAspect="1"/>
           </p:cNvPicPr>
@@ -3421,7 +3422,7 @@
         <p:spPr>
           <a:xfrm>
             <a:off x="0" y="0"/>
-            <a:ext cx="12191695" cy="6858000"/>
+            <a:ext cx="12192000" cy="6858000"/>
           </a:xfrm>
           <a:prstGeom prst="rect">
             <a:avLst/>
@@ -3448,7 +3449,7 @@
       <p:grpSpPr/>
       <p:pic>
         <p:nvPicPr>
-          <p:cNvPr id="2" name="Picture 1" descr="17-growth.png"/>
+          <p:cNvPr id="2" name="Picture 1" descr="17-people.png"/>
           <p:cNvPicPr>
             <a:picLocks noChangeAspect="1"/>
           </p:cNvPicPr>
@@ -3463,7 +3464,7 @@
         <p:spPr>
           <a:xfrm>
             <a:off x="0" y="0"/>
-            <a:ext cx="12191695" cy="6858000"/>
+            <a:ext cx="12192000" cy="6858000"/>
           </a:xfrm>
           <a:prstGeom prst="rect">
             <a:avLst/>
@@ -3490,7 +3491,7 @@
       <p:grpSpPr/>
       <p:pic>
         <p:nvPicPr>
-          <p:cNvPr id="2" name="Picture 1" descr="18-seats.png"/>
+          <p:cNvPr id="2" name="Picture 1" descr="18-growth.png"/>
           <p:cNvPicPr>
             <a:picLocks noChangeAspect="1"/>
           </p:cNvPicPr>
@@ -3505,7 +3506,7 @@
         <p:spPr>
           <a:xfrm>
             <a:off x="0" y="0"/>
-            <a:ext cx="12191695" cy="6858000"/>
+            <a:ext cx="12192000" cy="6858000"/>
           </a:xfrm>
           <a:prstGeom prst="rect">
             <a:avLst/>
@@ -3532,7 +3533,7 @@
       <p:grpSpPr/>
       <p:pic>
         <p:nvPicPr>
-          <p:cNvPr id="2" name="Picture 1" descr="19-scorecard.png"/>
+          <p:cNvPr id="2" name="Picture 1" descr="19-seats.png"/>
           <p:cNvPicPr>
             <a:picLocks noChangeAspect="1"/>
           </p:cNvPicPr>
@@ -3547,7 +3548,7 @@
         <p:spPr>
           <a:xfrm>
             <a:off x="0" y="0"/>
-            <a:ext cx="12191695" cy="6858000"/>
+            <a:ext cx="12192000" cy="6858000"/>
           </a:xfrm>
           <a:prstGeom prst="rect">
             <a:avLst/>
@@ -3589,7 +3590,7 @@
         <p:spPr>
           <a:xfrm>
             <a:off x="0" y="0"/>
-            <a:ext cx="12191695" cy="6858000"/>
+            <a:ext cx="12192000" cy="6858000"/>
           </a:xfrm>
           <a:prstGeom prst="rect">
             <a:avLst/>
@@ -3616,7 +3617,7 @@
       <p:grpSpPr/>
       <p:pic>
         <p:nvPicPr>
-          <p:cNvPr id="2" name="Picture 1" descr="20-roadmap.png"/>
+          <p:cNvPr id="2" name="Picture 1" descr="20-scorecard.png"/>
           <p:cNvPicPr>
             <a:picLocks noChangeAspect="1"/>
           </p:cNvPicPr>
@@ -3631,7 +3632,7 @@
         <p:spPr>
           <a:xfrm>
             <a:off x="0" y="0"/>
-            <a:ext cx="12191695" cy="6858000"/>
+            <a:ext cx="12192000" cy="6858000"/>
           </a:xfrm>
           <a:prstGeom prst="rect">
             <a:avLst/>
@@ -3658,7 +3659,7 @@
       <p:grpSpPr/>
       <p:pic>
         <p:nvPicPr>
-          <p:cNvPr id="2" name="Picture 1" descr="21-risks.png"/>
+          <p:cNvPr id="2" name="Picture 1" descr="21-roadmap.png"/>
           <p:cNvPicPr>
             <a:picLocks noChangeAspect="1"/>
           </p:cNvPicPr>
@@ -3673,7 +3674,7 @@
         <p:spPr>
           <a:xfrm>
             <a:off x="0" y="0"/>
-            <a:ext cx="12191695" cy="6858000"/>
+            <a:ext cx="12192000" cy="6858000"/>
           </a:xfrm>
           <a:prstGeom prst="rect">
             <a:avLst/>
@@ -3700,7 +3701,7 @@
       <p:grpSpPr/>
       <p:pic>
         <p:nvPicPr>
-          <p:cNvPr id="2" name="Picture 1" descr="22-decisions.png"/>
+          <p:cNvPr id="2" name="Picture 1" descr="22-risks.png"/>
           <p:cNvPicPr>
             <a:picLocks noChangeAspect="1"/>
           </p:cNvPicPr>
@@ -3715,7 +3716,7 @@
         <p:spPr>
           <a:xfrm>
             <a:off x="0" y="0"/>
-            <a:ext cx="12191695" cy="6858000"/>
+            <a:ext cx="12192000" cy="6858000"/>
           </a:xfrm>
           <a:prstGeom prst="rect">
             <a:avLst/>
@@ -3742,7 +3743,7 @@
       <p:grpSpPr/>
       <p:pic>
         <p:nvPicPr>
-          <p:cNvPr id="2" name="Picture 1" descr="23-glossary.png"/>
+          <p:cNvPr id="2" name="Picture 1" descr="23-decisions.png"/>
           <p:cNvPicPr>
             <a:picLocks noChangeAspect="1"/>
           </p:cNvPicPr>
@@ -3757,7 +3758,49 @@
         <p:spPr>
           <a:xfrm>
             <a:off x="0" y="0"/>
-            <a:ext cx="12191695" cy="6858000"/>
+            <a:ext cx="12192000" cy="6858000"/>
+          </a:xfrm>
+          <a:prstGeom prst="rect">
+            <a:avLst/>
+          </a:prstGeom>
+        </p:spPr>
+      </p:pic>
+    </p:spTree>
+  </p:cSld>
+  <p:clrMapOvr>
+    <a:masterClrMapping/>
+  </p:clrMapOvr>
+</p:sld>
+</file>
+
+<file path=ppt/slides/slide24.xml><?xml version="1.0" encoding="utf-8"?>
+<p:sld xmlns:a="http://schemas.openxmlformats.org/drawingml/2006/main" xmlns:p="http://schemas.openxmlformats.org/presentationml/2006/main" xmlns:r="http://schemas.openxmlformats.org/officeDocument/2006/relationships">
+  <p:cSld>
+    <p:spTree>
+      <p:nvGrpSpPr>
+        <p:cNvPr id="1" name=""/>
+        <p:cNvGrpSpPr/>
+        <p:nvPr/>
+      </p:nvGrpSpPr>
+      <p:grpSpPr/>
+      <p:pic>
+        <p:nvPicPr>
+          <p:cNvPr id="2" name="Picture 1" descr="24-glossary.png"/>
+          <p:cNvPicPr>
+            <a:picLocks noChangeAspect="1"/>
+          </p:cNvPicPr>
+          <p:nvPr/>
+        </p:nvPicPr>
+        <p:blipFill>
+          <a:blip r:embed="rId2"/>
+          <a:stretch>
+            <a:fillRect/>
+          </a:stretch>
+        </p:blipFill>
+        <p:spPr>
+          <a:xfrm>
+            <a:off x="0" y="0"/>
+            <a:ext cx="12192000" cy="6858000"/>
           </a:xfrm>
           <a:prstGeom prst="rect">
             <a:avLst/>
@@ -3799,7 +3842,7 @@
         <p:spPr>
           <a:xfrm>
             <a:off x="0" y="0"/>
-            <a:ext cx="12191695" cy="6858000"/>
+            <a:ext cx="12192000" cy="6858000"/>
           </a:xfrm>
           <a:prstGeom prst="rect">
             <a:avLst/>
@@ -3841,7 +3884,7 @@
         <p:spPr>
           <a:xfrm>
             <a:off x="0" y="0"/>
-            <a:ext cx="12191695" cy="6858000"/>
+            <a:ext cx="12192000" cy="6858000"/>
           </a:xfrm>
           <a:prstGeom prst="rect">
             <a:avLst/>
@@ -3883,7 +3926,7 @@
         <p:spPr>
           <a:xfrm>
             <a:off x="0" y="0"/>
-            <a:ext cx="12191695" cy="6858000"/>
+            <a:ext cx="12192000" cy="6858000"/>
           </a:xfrm>
           <a:prstGeom prst="rect">
             <a:avLst/>
@@ -3925,7 +3968,7 @@
         <p:spPr>
           <a:xfrm>
             <a:off x="0" y="0"/>
-            <a:ext cx="12191695" cy="6858000"/>
+            <a:ext cx="12192000" cy="6858000"/>
           </a:xfrm>
           <a:prstGeom prst="rect">
             <a:avLst/>
@@ -3967,7 +4010,7 @@
         <p:spPr>
           <a:xfrm>
             <a:off x="0" y="0"/>
-            <a:ext cx="12191695" cy="6858000"/>
+            <a:ext cx="12192000" cy="6858000"/>
           </a:xfrm>
           <a:prstGeom prst="rect">
             <a:avLst/>
@@ -4009,7 +4052,7 @@
         <p:spPr>
           <a:xfrm>
             <a:off x="0" y="0"/>
-            <a:ext cx="12191695" cy="6858000"/>
+            <a:ext cx="12192000" cy="6858000"/>
           </a:xfrm>
           <a:prstGeom prst="rect">
             <a:avLst/>
@@ -4051,7 +4094,7 @@
         <p:spPr>
           <a:xfrm>
             <a:off x="0" y="0"/>
-            <a:ext cx="12191695" cy="6858000"/>
+            <a:ext cx="12192000" cy="6858000"/>
           </a:xfrm>
           <a:prstGeom prst="rect">
             <a:avLst/>

</xml_diff>